<commit_message>
update for bullets & other fixes
</commit_message>
<xml_diff>
--- a/scripts/PowerPoint Slide Inventory Script/ibm_yaml_test_v6.pptx
+++ b/scripts/PowerPoint Slide Inventory Script/ibm_yaml_test_v6.pptx
@@ -20,6 +20,7 @@
     <p:sldId id="262" r:id="rId15"/>
     <p:sldId id="263" r:id="rId16"/>
     <p:sldId id="264" r:id="rId17"/>
+    <p:sldId id="265" r:id="rId18"/>
   </p:sldIdLst>
   <p:sldSz cx="9144000" cy="5143500" type="screen16x9"/>
   <p:notesSz cx="6858000" cy="9144000"/>
@@ -13227,7 +13228,102 @@
           <a:lstStyle/>
           <a:p>
             <a:r>
-              <a:t>Structured PoC slide generation can preserve narrative clarity</a:t>
+              <a:t>Spreadsheet logic can be replatformed into Fabric without losing operational clarity</a:t>
+            </a:r>
+          </a:p>
+        </p:txBody>
+      </p:sp>
+    </p:spTree>
+  </p:cSld>
+  <p:clrMapOvr>
+    <a:masterClrMapping/>
+  </p:clrMapOvr>
+</p:sld>
+</file>
+
+<file path=ppt/slides/slide10.xml><?xml version="1.0" encoding="utf-8"?>
+<p:sld xmlns:a="http://schemas.openxmlformats.org/drawingml/2006/main" xmlns:p="http://schemas.openxmlformats.org/presentationml/2006/main" xmlns:r="http://schemas.openxmlformats.org/officeDocument/2006/relationships">
+  <p:cSld>
+    <p:spTree>
+      <p:nvGrpSpPr>
+        <p:cNvPr id="1" name=""/>
+        <p:cNvGrpSpPr/>
+        <p:nvPr/>
+      </p:nvGrpSpPr>
+      <p:grpSpPr/>
+      <p:sp>
+        <p:nvSpPr>
+          <p:cNvPr id="2" name="Title 1"/>
+          <p:cNvSpPr>
+            <a:spLocks noGrp="1"/>
+          </p:cNvSpPr>
+          <p:nvPr>
+            <p:ph type="title"/>
+          </p:nvPr>
+        </p:nvSpPr>
+        <p:spPr/>
+        <p:txBody>
+          <a:bodyPr/>
+          <a:lstStyle/>
+          <a:p>
+            <a:r>
+              <a:t>The next step is to operationalise the pattern</a:t>
+            </a:r>
+          </a:p>
+        </p:txBody>
+      </p:sp>
+      <p:sp>
+        <p:nvSpPr>
+          <p:cNvPr id="3" name="Text Placeholder 2"/>
+          <p:cNvSpPr>
+            <a:spLocks noGrp="1"/>
+          </p:cNvSpPr>
+          <p:nvPr>
+            <p:ph type="body" idx="13" sz="quarter"/>
+          </p:nvPr>
+        </p:nvSpPr>
+        <p:spPr/>
+        <p:txBody>
+          <a:bodyPr/>
+          <a:lstStyle/>
+          <a:p>
+            <a:pPr/>
+            <a:r>
+              <a:t>Refine the ingestion trigger and metadata controls</a:t>
+            </a:r>
+          </a:p>
+          <a:p>
+            <a:pPr/>
+            <a:r>
+              <a:t>Harden the notebook pattern for repeatable execution</a:t>
+            </a:r>
+          </a:p>
+        </p:txBody>
+      </p:sp>
+      <p:sp>
+        <p:nvSpPr>
+          <p:cNvPr id="4" name="Text Placeholder 3"/>
+          <p:cNvSpPr>
+            <a:spLocks noGrp="1"/>
+          </p:cNvSpPr>
+          <p:nvPr>
+            <p:ph type="body" idx="12" sz="quarter"/>
+          </p:nvPr>
+        </p:nvSpPr>
+        <p:spPr/>
+        <p:txBody>
+          <a:bodyPr/>
+          <a:lstStyle/>
+          <a:p>
+            <a:pPr/>
+            <a:r>
+              <a:t>Extend the lakehouse outputs for downstream reasoning</a:t>
+            </a:r>
+          </a:p>
+          <a:p>
+            <a:pPr/>
+            <a:r>
+              <a:t>Connect the flow into reporting and broader automation</a:t>
             </a:r>
           </a:p>
         </p:txBody>
@@ -13266,7 +13362,7 @@
           <a:lstStyle/>
           <a:p>
             <a:r>
-              <a:t>Manual PoC slide creation introduces inconsistency</a:t>
+              <a:t>A manual spreadsheet-driven process was becoming difficult to scale and govern</a:t>
             </a:r>
           </a:p>
         </p:txBody>
@@ -13288,25 +13384,25 @@
           <a:p>
             <a:pPr/>
             <a:r>
-              <a:t>Narrative structure varies between engagements</a:t>
+              <a:t>Business logic was embedded in spreadsheets rather than a managed execution layer</a:t>
             </a:r>
           </a:p>
           <a:p>
             <a:pPr/>
             <a:r>
-              <a:t>Slides often become overly text dense</a:t>
+              <a:t>The process depended on manual handling before files could move into the data platform</a:t>
             </a:r>
           </a:p>
           <a:p>
             <a:pPr/>
             <a:r>
-              <a:t>Formatting effort distracts from reasoning</a:t>
+              <a:t>Auditability and repeatability were weaker than the target operating model required</a:t>
             </a:r>
           </a:p>
           <a:p>
             <a:pPr/>
             <a:r>
-              <a:t>A repeatable structure would improve clarity</a:t>
+              <a:t>The question was whether Fabric notebooks could preserve the logic while improving control</a:t>
             </a:r>
           </a:p>
         </p:txBody>
@@ -13345,7 +13441,7 @@
           <a:lstStyle/>
           <a:p>
             <a:r>
-              <a:t>The PoC must prove both narrative discipline and technical feasibility</a:t>
+              <a:t>The PoC needed to prove both functional equivalence and platform suitability</a:t>
             </a:r>
           </a:p>
         </p:txBody>
@@ -13367,13 +13463,13 @@
           <a:p>
             <a:pPr/>
             <a:r>
-              <a:t>Can a PoC narrative arc be expressed as structured data?</a:t>
+              <a:t>Can the spreadsheet logic be translated into Python notebooks accurately?</a:t>
             </a:r>
           </a:p>
           <a:p>
             <a:pPr/>
             <a:r>
-              <a:t>Can titles and bullets be constrained automatically?</a:t>
+              <a:t>Can the resulting process operate cleanly inside a Fabric and lakehouse pattern?</a:t>
             </a:r>
           </a:p>
         </p:txBody>
@@ -13395,13 +13491,13 @@
           <a:p>
             <a:pPr/>
             <a:r>
-              <a:t>Can PowerPoint templates be inspected reliably?</a:t>
+              <a:t>Can ingestion and downstream reasoning be made more repeatable?</a:t>
             </a:r>
           </a:p>
           <a:p>
             <a:pPr/>
             <a:r>
-              <a:t>Can layouts be populated deterministically from Python?</a:t>
+              <a:t>Can the approach improve observability without introducing unnecessary complexity?</a:t>
             </a:r>
           </a:p>
         </p:txBody>
@@ -13440,7 +13536,7 @@
           <a:lstStyle/>
           <a:p>
             <a:r>
-              <a:t>Several paths were available, but only one balanced structure and control</a:t>
+              <a:t>Several implementation paths existed, but they did not offer the same balance of control</a:t>
             </a:r>
           </a:p>
         </p:txBody>
@@ -13462,19 +13558,19 @@
           <a:p>
             <a:pPr/>
             <a:r>
-              <a:t>Free AI slide generation</a:t>
+              <a:t>Retain the spreadsheet as the core execution mechanism</a:t>
             </a:r>
           </a:p>
           <a:p>
             <a:pPr/>
             <a:r>
-              <a:t>High flexibility</a:t>
+              <a:t>Low change effort</a:t>
             </a:r>
           </a:p>
           <a:p>
             <a:pPr/>
             <a:r>
-              <a:t>Weak layout discipline</a:t>
+              <a:t>But governance and automation remain constrained</a:t>
             </a:r>
           </a:p>
         </p:txBody>
@@ -13496,19 +13592,19 @@
           <a:p>
             <a:pPr/>
             <a:r>
-              <a:t>Template-driven rendering</a:t>
+              <a:t>Move the logic into Fabric notebooks backed by the lakehouse</a:t>
             </a:r>
           </a:p>
           <a:p>
             <a:pPr/>
             <a:r>
-              <a:t>Lower freedom</a:t>
+              <a:t>More engineering effort up front</a:t>
             </a:r>
           </a:p>
           <a:p>
             <a:pPr/>
             <a:r>
-              <a:t>Much stronger consistency</a:t>
+              <a:t>But stronger repeatability, visibility and integration potential</a:t>
             </a:r>
           </a:p>
         </p:txBody>
@@ -13547,7 +13643,7 @@
           <a:lstStyle/>
           <a:p>
             <a:r>
-              <a:t>The chosen approach separates reasoning, rendering and template control</a:t>
+              <a:t>The chosen approach moved logic into Python notebooks while keeping ingestion disciplined</a:t>
             </a:r>
           </a:p>
         </p:txBody>
@@ -13569,19 +13665,19 @@
           <a:p>
             <a:pPr/>
             <a:r>
-              <a:t>Narrative intent is defined in structured YAML</a:t>
+              <a:t>The spreadsheet process was treated as logic to be translated rather than simply automated around</a:t>
             </a:r>
           </a:p>
           <a:p>
             <a:pPr/>
             <a:r>
-              <a:t>The renderer maps modalities to approved layouts</a:t>
+              <a:t>Fabric notebooks became the execution layer for that logic</a:t>
             </a:r>
           </a:p>
           <a:p>
             <a:pPr/>
             <a:r>
-              <a:t>The template enforces visual consistency</a:t>
+              <a:t>The surrounding flow was designed to support controlled ingestion into the lakehouse</a:t>
             </a:r>
           </a:p>
         </p:txBody>
@@ -13620,7 +13716,7 @@
           <a:lstStyle/>
           <a:p>
             <a:r>
-              <a:t>Architecture: narrative-driven slide generation pipeline</a:t>
+              <a:t>Architecture: spreadsheet ingestion and notebook-driven execution in Fabric</a:t>
             </a:r>
           </a:p>
         </p:txBody>
@@ -13642,19 +13738,19 @@
           <a:p>
             <a:pPr/>
             <a:r>
-              <a:t>Narrative arc expressed as structured input</a:t>
+              <a:t>Files are prepared and moved into a governed ingestion path</a:t>
             </a:r>
           </a:p>
           <a:p>
             <a:pPr/>
             <a:r>
-              <a:t>AI generates constrained slide content</a:t>
+              <a:t>Python notebooks execute the translated business logic inside Fabric</a:t>
             </a:r>
           </a:p>
           <a:p>
             <a:pPr/>
             <a:r>
-              <a:t>Template layouts enforce spatial discipline</a:t>
+              <a:t>Outputs land in the lakehouse ready for downstream reasoning and reporting</a:t>
             </a:r>
           </a:p>
         </p:txBody>
@@ -13760,7 +13856,7 @@
           <a:lstStyle/>
           <a:p>
             <a:r>
-              <a:t>The mechanics are now proven, but image handling and modality growth remain</a:t>
+              <a:t>The PoC proved the logic could move into Fabric cleanly</a:t>
             </a:r>
           </a:p>
         </p:txBody>
@@ -13782,28 +13878,40 @@
           <a:p>
             <a:pPr/>
             <a:r>
-              <a:t>Template conversion from POTX to PPTX works locally</a:t>
+              <a:t>A meaningful representation of the spreadsheet process was implemented in Python notebooks</a:t>
             </a:r>
           </a:p>
           <a:p>
             <a:pPr/>
             <a:r>
-              <a:t>IBM placeholder mappings are now reliable</a:t>
+              <a:t>The Fabric environment proved viable as the execution surface for the translated logic</a:t>
             </a:r>
           </a:p>
           <a:p>
             <a:pPr/>
             <a:r>
-              <a:t>Picture insertion requires controlled image sizing</a:t>
+              <a:t>The resulting pattern aligned better with a repeatable ingestion and processing model</a:t>
             </a:r>
           </a:p>
           <a:p>
             <a:pPr/>
             <a:r>
-              <a:t>The next step is to expand modality coverage carefully</a:t>
-            </a:r>
-          </a:p>
-        </p:txBody>
+              <a:t>The flow created a stronger foundation for later automation and reporting</a:t>
+            </a:r>
+          </a:p>
+        </p:txBody>
+      </p:sp>
+      <p:sp>
+        <p:nvSpPr>
+          <p:cNvPr id="4" name="Picture Placeholder 3"/>
+          <p:cNvSpPr>
+            <a:spLocks noGrp="1"/>
+          </p:cNvSpPr>
+          <p:nvPr>
+            <p:ph type="pic" idx="13" sz="quarter"/>
+          </p:nvPr>
+        </p:nvSpPr>
+        <p:spPr/>
       </p:sp>
     </p:spTree>
   </p:cSld>
@@ -13839,7 +13947,7 @@
           <a:lstStyle/>
           <a:p>
             <a:r>
-              <a:t>The generator can now evolve independently of the visual theme</a:t>
+              <a:t>The main lessons were about process discipline and hidden dependency, not notebook feasibility</a:t>
             </a:r>
           </a:p>
         </p:txBody>
@@ -13861,19 +13969,25 @@
           <a:p>
             <a:pPr/>
             <a:r>
-              <a:t>Narrative structure is no longer tied directly to IBM layout names</a:t>
+              <a:t>The hard part was not notebook execution but surfacing the implicit assumptions held in the spreadsheet</a:t>
             </a:r>
           </a:p>
           <a:p>
             <a:pPr/>
             <a:r>
-              <a:t>The same modalities could later map to Microsoft-themed layouts</a:t>
+              <a:t>Human intervention remained useful at the ingestion boundary where source quality varied</a:t>
             </a:r>
           </a:p>
           <a:p>
             <a:pPr/>
             <a:r>
-              <a:t>Claude can generate content without needing PowerPoint awareness</a:t>
+              <a:t>Folder and metadata handling mattered more than expected in making the flow reliable</a:t>
+            </a:r>
+          </a:p>
+          <a:p>
+            <a:pPr/>
+            <a:r>
+              <a:t>A controlled trigger point was preferable to trying to automate around partially prepared inputs</a:t>
             </a:r>
           </a:p>
         </p:txBody>
@@ -13912,7 +14026,7 @@
           <a:lstStyle/>
           <a:p>
             <a:r>
-              <a:t>The next phase is to formalise schema and extend supported slide types</a:t>
+              <a:t>The outcome supports a broader move from spreadsheet operations to platform-managed execution</a:t>
             </a:r>
           </a:p>
         </p:txBody>
@@ -13924,7 +14038,7 @@
             <a:spLocks noGrp="1"/>
           </p:cNvSpPr>
           <p:nvPr>
-            <p:ph type="body" idx="13" sz="quarter"/>
+            <p:ph type="body" idx="12" sz="quarter"/>
           </p:nvPr>
         </p:nvSpPr>
         <p:spPr/>
@@ -13934,41 +14048,19 @@
           <a:p>
             <a:pPr/>
             <a:r>
-              <a:t>Add evidence and results modality</a:t>
+              <a:t>The logic no longer needs to remain trapped inside a manually operated spreadsheet</a:t>
             </a:r>
           </a:p>
           <a:p>
             <a:pPr/>
             <a:r>
-              <a:t>Add options considered modality</a:t>
-            </a:r>
-          </a:p>
-        </p:txBody>
-      </p:sp>
-      <p:sp>
-        <p:nvSpPr>
-          <p:cNvPr id="4" name="Text Placeholder 3"/>
-          <p:cNvSpPr>
-            <a:spLocks noGrp="1"/>
-          </p:cNvSpPr>
-          <p:nvPr>
-            <p:ph type="body" idx="12" sz="quarter"/>
-          </p:nvPr>
-        </p:nvSpPr>
-        <p:spPr/>
-        <p:txBody>
-          <a:bodyPr/>
-          <a:lstStyle/>
+              <a:t>Fabric can act as both an execution environment and a bridge into more governed data handling</a:t>
+            </a:r>
+          </a:p>
           <a:p>
             <a:pPr/>
             <a:r>
-              <a:t>Define a proper JSON or YAML schema</a:t>
-            </a:r>
-          </a:p>
-          <a:p>
-            <a:pPr/>
-            <a:r>
-              <a:t>Introduce validation for text density and image sizing</a:t>
+              <a:t>Future automation should focus on reliable ingestion conditions rather than forcing full end-to-end autonomy</a:t>
             </a:r>
           </a:p>
         </p:txBody>

</xml_diff>